<commit_message>
Strict range operators, Nemotron LLM fallback
</commit_message>
<xml_diff>
--- a/report/epaData-slides.pptx
+++ b/report/epaData-slides.pptx
@@ -869,13 +869,13 @@
 • Set four filters on the Unit-years tab.
     – Clear filters · Unit-years tab
     – State = KY · Fuel = Coal · Year = 2025
-    – Advanced → CO₂ min = 500000
+    – Advanced → CO₂ min = 500000 · click ≥ beside it to make it strict (&gt;), as in “greater than”
 • Result: 25 unit-years.
     – switch to Facilities: the same filters give 8 facilities
 • The conditions sit on three tables, combined with AND.
     – state → facility · fuel → unit · year and CO₂ → annual record
 • The whole search lives in the URL.
-    – point at the address bar: /explore?tab=units&amp;stateCode=KY&amp;primaryFuel=Coal&amp;year=2025&amp;co2MassTonsMin=500000
+    – point at the address bar: /explore?tab=units&amp;stateCode=KY&amp;primaryFuel=Coal&amp;year=2025&amp;co2MassTonsMin=500000&amp;co2MassTonsMinStrict=1
     – bookmark or share it; the CSV export parses the same URL
 • Fuel and control filters match by substring.
     – CAMPD stores combined values like “Coal, Pipeline Natural Gas”
@@ -4730,7 +4730,7 @@
                   <a:srgbClr val="2A1F16"/>
                 </a:solidFill>
               </a:rPr>
-              <a:t>KY + Coal + 2025 + CO₂ ≥ 500,000 t</a:t>
+              <a:t>KY + Coal + 2025 + CO₂ &gt; 500,000 t</a:t>
             </a:r>
             <a:pPr indent="0" marL="0">
               <a:lnSpc>
@@ -5300,6 +5300,83 @@
                 <a:cs typeface="IBM Plex Mono" pitchFamily="34" charset="-120"/>
               </a:rPr>
               <a:t>500000</a:t>
+            </a:r>
+            <a:endParaRPr lang="en-US" sz="1300" dirty="0"/>
+          </a:p>
+          <a:p>
+            <a:pPr indent="0" marL="0">
+              <a:lnSpc>
+                <a:spcPct val="112000"/>
+              </a:lnSpc>
+              <a:buNone/>
+            </a:pPr>
+            <a:pPr indent="0" marL="0">
+              <a:lnSpc>
+                <a:spcPct val="112000"/>
+              </a:lnSpc>
+              <a:buNone/>
+            </a:pPr>
+            <a:r>
+              <a:rPr lang="en-US" sz="1300" dirty="0">
+                <a:solidFill>
+                  <a:srgbClr val="AB9A88"/>
+                </a:solidFill>
+                <a:latin typeface="IBM Plex Mono" pitchFamily="34" charset="0"/>
+                <a:ea typeface="IBM Plex Mono" pitchFamily="34" charset="-122"/>
+                <a:cs typeface="IBM Plex Mono" pitchFamily="34" charset="-120"/>
+              </a:rPr>
+              <a:t>&amp;</a:t>
+            </a:r>
+            <a:pPr indent="0" marL="0">
+              <a:lnSpc>
+                <a:spcPct val="112000"/>
+              </a:lnSpc>
+              <a:buNone/>
+            </a:pPr>
+            <a:r>
+              <a:rPr lang="en-US" sz="1300" dirty="0">
+                <a:solidFill>
+                  <a:srgbClr val="F4EDE4"/>
+                </a:solidFill>
+                <a:latin typeface="IBM Plex Mono" pitchFamily="34" charset="0"/>
+                <a:ea typeface="IBM Plex Mono" pitchFamily="34" charset="-122"/>
+                <a:cs typeface="IBM Plex Mono" pitchFamily="34" charset="-120"/>
+              </a:rPr>
+              <a:t>co2MassTonsMinStrict</a:t>
+            </a:r>
+            <a:pPr indent="0" marL="0">
+              <a:lnSpc>
+                <a:spcPct val="112000"/>
+              </a:lnSpc>
+              <a:buNone/>
+            </a:pPr>
+            <a:r>
+              <a:rPr lang="en-US" sz="1300" dirty="0">
+                <a:solidFill>
+                  <a:srgbClr val="AB9A88"/>
+                </a:solidFill>
+                <a:latin typeface="IBM Plex Mono" pitchFamily="34" charset="0"/>
+                <a:ea typeface="IBM Plex Mono" pitchFamily="34" charset="-122"/>
+                <a:cs typeface="IBM Plex Mono" pitchFamily="34" charset="-120"/>
+              </a:rPr>
+              <a:t>=</a:t>
+            </a:r>
+            <a:pPr indent="0" marL="0">
+              <a:lnSpc>
+                <a:spcPct val="112000"/>
+              </a:lnSpc>
+              <a:buNone/>
+            </a:pPr>
+            <a:r>
+              <a:rPr lang="en-US" sz="1300" dirty="0">
+                <a:solidFill>
+                  <a:srgbClr val="F4EDE4"/>
+                </a:solidFill>
+                <a:latin typeface="IBM Plex Mono" pitchFamily="34" charset="0"/>
+                <a:ea typeface="IBM Plex Mono" pitchFamily="34" charset="-122"/>
+                <a:cs typeface="IBM Plex Mono" pitchFamily="34" charset="-120"/>
+              </a:rPr>
+              <a:t>1</a:t>
             </a:r>
             <a:endParaRPr lang="en-US" sz="1300" dirty="0"/>
           </a:p>

</xml_diff>